<commit_message>
switch to rwo mode and 1 replica
</commit_message>
<xml_diff>
--- a/kubernetes/05_persistence.pptx
+++ b/kubernetes/05_persistence.pptx
@@ -272,7 +272,7 @@
             <a:fld id="{47855BD9-AF71-426C-9B9B-B0E52B88852E}" type="slidenum">
               <a:rPr lang="de-DE" sz="1000" smtClean="0"/>
               <a:pPr algn="ctr"/>
-              <a:t>‹#›</a:t>
+              <a:t>‹Nr.›</a:t>
             </a:fld>
             <a:endParaRPr lang="de-DE" sz="1000" dirty="0"/>
           </a:p>
@@ -421,7 +421,7 @@
             <a:fld id="{7D8C2C35-2B8A-446E-BEC0-FD36716C29AC}" type="slidenum">
               <a:rPr lang="de-DE" smtClean="0"/>
               <a:pPr/>
-              <a:t>‹#›</a:t>
+              <a:t>‹Nr.›</a:t>
             </a:fld>
             <a:endParaRPr lang="de-DE" dirty="0"/>
           </a:p>
@@ -1653,7 +1653,9 @@
         </p:nvSpPr>
         <p:spPr/>
         <p:txBody>
-          <a:bodyPr/>
+          <a:bodyPr>
+            <a:normAutofit lnSpcReduction="10000"/>
+          </a:bodyPr>
           <a:lstStyle/>
           <a:p>
             <a:pPr marL="285750" marR="0" lvl="0" indent="-285750" algn="l" defTabSz="1088776" rtl="0" eaLnBrk="1" fontAlgn="auto" latinLnBrk="0" hangingPunct="1">
@@ -1682,6 +1684,76 @@
               <a:t>yaml</a:t>
             </a:r>
             <a:endParaRPr lang="en-US" baseline="0" dirty="0"/>
+          </a:p>
+          <a:p>
+            <a:pPr marL="285750" marR="0" lvl="0" indent="-285750" algn="l" defTabSz="1088776" rtl="0" eaLnBrk="1" fontAlgn="auto" latinLnBrk="0" hangingPunct="1">
+              <a:lnSpc>
+                <a:spcPct val="100000"/>
+              </a:lnSpc>
+              <a:spcBef>
+                <a:spcPts val="0"/>
+              </a:spcBef>
+              <a:spcAft>
+                <a:spcPts val="0"/>
+              </a:spcAft>
+              <a:buClrTx/>
+              <a:buSzTx/>
+              <a:buFontTx/>
+              <a:buChar char="-"/>
+              <a:tabLst/>
+              <a:defRPr/>
+            </a:pPr>
+            <a:r>
+              <a:rPr lang="en-US" baseline="0" dirty="0"/>
+              <a:t>Explain the </a:t>
+            </a:r>
+            <a:r>
+              <a:rPr lang="en-US" baseline="0" dirty="0" err="1"/>
+              <a:t>waitForFirstConsumer</a:t>
+            </a:r>
+            <a:r>
+              <a:rPr lang="en-US" baseline="0" dirty="0"/>
+              <a:t> Policy (storage class will provision the PV only when a pod actually requests to mount the </a:t>
+            </a:r>
+            <a:r>
+              <a:rPr lang="en-US" baseline="0" dirty="0" err="1"/>
+              <a:t>pvc</a:t>
+            </a:r>
+            <a:r>
+              <a:rPr lang="en-US" baseline="0" dirty="0"/>
+              <a:t>)</a:t>
+            </a:r>
+          </a:p>
+          <a:p>
+            <a:pPr marL="285750" marR="0" lvl="0" indent="-285750" algn="l" defTabSz="1088776" rtl="0" eaLnBrk="1" fontAlgn="auto" latinLnBrk="0" hangingPunct="1">
+              <a:lnSpc>
+                <a:spcPct val="100000"/>
+              </a:lnSpc>
+              <a:spcBef>
+                <a:spcPts val="0"/>
+              </a:spcBef>
+              <a:spcAft>
+                <a:spcPts val="0"/>
+              </a:spcAft>
+              <a:buClrTx/>
+              <a:buSzTx/>
+              <a:buFontTx/>
+              <a:buChar char="-"/>
+              <a:tabLst/>
+              <a:defRPr/>
+            </a:pPr>
+            <a:r>
+              <a:rPr lang="en-US" baseline="0" dirty="0"/>
+              <a:t>Create a deployment which mounts the PVC. Discuss the volume &amp; </a:t>
+            </a:r>
+            <a:r>
+              <a:rPr lang="en-US" baseline="0" dirty="0" err="1"/>
+              <a:t>volumeMount</a:t>
+            </a:r>
+            <a:r>
+              <a:rPr lang="en-US" baseline="0" dirty="0"/>
+              <a:t> section and highlight the matching names for the volume within the pod spec to make it referenceable.</a:t>
+            </a:r>
           </a:p>
           <a:p>
             <a:pPr marL="285750" marR="0" lvl="0" indent="-285750" algn="l" defTabSz="1088776" rtl="0" eaLnBrk="1" fontAlgn="auto" latinLnBrk="0" hangingPunct="1">
@@ -1809,15 +1881,7 @@
             </a:pPr>
             <a:r>
               <a:rPr lang="en-US" baseline="0" dirty="0"/>
-              <a:t>Create a pod where the PVC is mounted. Discuss the volume &amp; </a:t>
-            </a:r>
-            <a:r>
-              <a:rPr lang="en-US" baseline="0" dirty="0" err="1"/>
-              <a:t>volumeMount</a:t>
-            </a:r>
-            <a:r>
-              <a:rPr lang="en-US" baseline="0" dirty="0"/>
-              <a:t> section and highlight the matching names for the volume within the pod spec to make it referenceable.</a:t>
+              <a:t>Once the pod is created, logon to it and create some content.</a:t>
             </a:r>
           </a:p>
           <a:p>
@@ -1838,10 +1902,7 @@
               <a:tabLst/>
               <a:defRPr/>
             </a:pPr>
-            <a:r>
-              <a:rPr lang="en-US" baseline="0" dirty="0"/>
-              <a:t>Once the pod is created, logon to it and create some content.</a:t>
-            </a:r>
+            <a:endParaRPr lang="en-US" baseline="0" dirty="0"/>
           </a:p>
           <a:p>
             <a:pPr marL="285750" marR="0" lvl="0" indent="-285750" algn="l" defTabSz="1088776" rtl="0" eaLnBrk="1" fontAlgn="auto" latinLnBrk="0" hangingPunct="1">
@@ -1863,15 +1924,7 @@
             </a:pPr>
             <a:r>
               <a:rPr lang="en-US" baseline="0" dirty="0"/>
-              <a:t>In parallel, create </a:t>
-            </a:r>
-            <a:r>
-              <a:rPr lang="en-US" baseline="0"/>
-              <a:t>a deployment </a:t>
-            </a:r>
-            <a:r>
-              <a:rPr lang="en-US" baseline="0" dirty="0"/>
-              <a:t>that attempts to mount the same PVC. </a:t>
+              <a:t>Next, scale the deployment that attempts to mount the same PVC. </a:t>
             </a:r>
           </a:p>
           <a:p>
@@ -1948,8 +2001,21 @@
             </a:pPr>
             <a:r>
               <a:rPr lang="en-US" baseline="0" dirty="0"/>
-              <a:t>To get the example working the first pod would need to be removed and all other pods would  need to be re-created.</a:t>
-            </a:r>
+              <a:t>Highlight, that if a pod already runs on a node and mounts a volume a 2</a:t>
+            </a:r>
+            <a:r>
+              <a:rPr lang="en-US" baseline="30000" dirty="0"/>
+              <a:t>nd</a:t>
+            </a:r>
+            <a:r>
+              <a:rPr lang="en-US" baseline="0" dirty="0"/>
+              <a:t> pod can start on the same node and also use this volume (which of course </a:t>
+            </a:r>
+            <a:r>
+              <a:rPr lang="en-US" baseline="0"/>
+              <a:t>is dangerous) </a:t>
+            </a:r>
+            <a:endParaRPr lang="en-US" baseline="0" dirty="0"/>
           </a:p>
         </p:txBody>
       </p:sp>
@@ -18870,7 +18936,7 @@
               <a:pPr marL="0" lvl="0" indent="0" algn="r">
                 <a:buNone/>
               </a:pPr>
-              <a:t>‹#›</a:t>
+              <a:t>‹Nr.›</a:t>
             </a:fld>
             <a:endParaRPr lang="en-US" sz="900" noProof="0" dirty="0"/>
           </a:p>

</xml_diff>